<commit_message>
feat: implement backend service architecture and ML service components while removing docker-compose configuration.
</commit_message>
<xml_diff>
--- a/Deliverable/EcoSphere_Proposal_Review.pptx
+++ b/Deliverable/EcoSphere_Proposal_Review.pptx
@@ -2228,6 +2228,10 @@
             </a:srgbClr>
           </a:solidFill>
         </p:spPr>
+        <p:txBody>
+          <a:bodyPr/>
+          <a:p/>
+        </p:txBody>
       </p:sp>
       <p:sp>
         <p:nvSpPr>
@@ -2249,6 +2253,10 @@
             </a:srgbClr>
           </a:solidFill>
         </p:spPr>
+        <p:txBody>
+          <a:bodyPr/>
+          <a:p/>
+        </p:txBody>
       </p:sp>
       <p:sp>
         <p:nvSpPr>
@@ -2313,6 +2321,10 @@
             </a:outerShdw>
           </a:effectLst>
         </p:spPr>
+        <p:txBody>
+          <a:bodyPr/>
+          <a:p/>
+        </p:txBody>
       </p:sp>
       <p:pic>
         <p:nvPicPr>
@@ -2436,6 +2448,10 @@
             <a:prstDash val="solid"/>
           </a:ln>
         </p:spPr>
+        <p:txBody>
+          <a:bodyPr/>
+          <a:p/>
+        </p:txBody>
       </p:sp>
       <p:sp>
         <p:nvSpPr>
@@ -2599,6 +2615,10 @@
             <a:prstDash val="solid"/>
           </a:ln>
         </p:spPr>
+        <p:txBody>
+          <a:bodyPr/>
+          <a:p/>
+        </p:txBody>
       </p:sp>
       <p:pic>
         <p:nvPicPr>
@@ -2648,15 +2668,7 @@
               <a:buNone/>
             </a:pPr>
             <a:r>
-              <a:rPr lang="en-US" sz="1300" i="1" dirty="0">
-                <a:solidFill>
-                  <a:srgbClr val="FFFFFF"/>
-                </a:solidFill>
-                <a:latin typeface="Segoe UI" panose="020B0502040204020203" pitchFamily="34" charset="0"/>
-                <a:ea typeface="Segoe UI" panose="020B0502040204020203" pitchFamily="34" charset="-122"/>
-                <a:cs typeface="Segoe UI" panose="020B0502040204020203" pitchFamily="34" charset="-120"/>
-              </a:rPr>
-              <a:t>Intelligent Reference Implementation for Institutional &amp; Household Sustainability →</a:t>
+              <a:t>Full System Architectural Implementation &amp; Review</a:t>
             </a:r>
             <a:endParaRPr lang="en-US" sz="1300" dirty="0"/>
           </a:p>
@@ -2839,6 +2851,10 @@
             </a:outerShdw>
           </a:effectLst>
         </p:spPr>
+        <p:txBody>
+          <a:bodyPr/>
+          <a:p/>
+        </p:txBody>
       </p:sp>
       <p:sp>
         <p:nvSpPr>
@@ -2865,6 +2881,10 @@
             </a:outerShdw>
           </a:effectLst>
         </p:spPr>
+        <p:txBody>
+          <a:bodyPr/>
+          <a:p/>
+        </p:txBody>
       </p:sp>
       <p:pic>
         <p:nvPicPr>
@@ -2914,15 +2934,7 @@
               <a:buNone/>
             </a:pPr>
             <a:r>
-              <a:rPr lang="en-US" sz="1750" b="1" dirty="0">
-                <a:solidFill>
-                  <a:srgbClr val="156D4F"/>
-                </a:solidFill>
-                <a:latin typeface="Segoe UI" panose="020B0502040204020203" pitchFamily="34" charset="0"/>
-                <a:ea typeface="Segoe UI" panose="020B0502040204020203" pitchFamily="34" charset="-122"/>
-                <a:cs typeface="Segoe UI" panose="020B0502040204020203" pitchFamily="34" charset="-120"/>
-              </a:rPr>
-              <a:t>React.js Frontend Client</a:t>
+              <a:t>React 18 Spatial Canvas Client</a:t>
             </a:r>
             <a:endParaRPr lang="en-US" sz="1750" dirty="0"/>
           </a:p>
@@ -2979,15 +2991,7 @@
               <a:buNone/>
             </a:pPr>
             <a:r>
-              <a:rPr lang="en-US" sz="1250" dirty="0">
-                <a:solidFill>
-                  <a:srgbClr val="364327"/>
-                </a:solidFill>
-                <a:latin typeface="Segoe UI" panose="020B0502040204020203" pitchFamily="34" charset="0"/>
-                <a:ea typeface="Segoe UI" panose="020B0502040204020203" pitchFamily="34" charset="-122"/>
-                <a:cs typeface="Segoe UI" panose="020B0502040204020203" pitchFamily="34" charset="-120"/>
-              </a:rPr>
-              <a:t>Interactive Dashboards: Renders carbon metrics, water and electricity charts using Apache ECharts.</a:t>
+              <a:t>Spatial Canvas Workspace: 2D infinite workspace with drag-to-pan, SVG data streams, and 12 interactive nodes.</a:t>
             </a:r>
             <a:endParaRPr lang="en-US" sz="1250" dirty="0"/>
           </a:p>
@@ -3174,15 +3178,7 @@
               <a:buNone/>
             </a:pPr>
             <a:r>
-              <a:rPr lang="en-US" sz="1250" dirty="0">
-                <a:solidFill>
-                  <a:srgbClr val="364327"/>
-                </a:solidFill>
-                <a:latin typeface="Segoe UI" panose="020B0502040204020203" pitchFamily="34" charset="0"/>
-                <a:ea typeface="Segoe UI" panose="020B0502040204020203" pitchFamily="34" charset="-122"/>
-                <a:cs typeface="Segoe UI" panose="020B0502040204020203" pitchFamily="34" charset="-120"/>
-              </a:rPr>
-              <a:t>AI Assistant Chat: Instant interface to ask questions and request decision explanations.</a:t>
+              <a:t>Groq AI Omnibar &amp; Assistant: Floating command bar with natural language intent parser and instant chat.</a:t>
             </a:r>
             <a:endParaRPr lang="en-US" sz="1250" dirty="0"/>
           </a:p>
@@ -3280,6 +3276,10 @@
             </a:outerShdw>
           </a:effectLst>
         </p:spPr>
+        <p:txBody>
+          <a:bodyPr/>
+          <a:p/>
+        </p:txBody>
       </p:sp>
       <p:sp>
         <p:nvSpPr>
@@ -3306,6 +3306,10 @@
             </a:outerShdw>
           </a:effectLst>
         </p:spPr>
+        <p:txBody>
+          <a:bodyPr/>
+          <a:p/>
+        </p:txBody>
       </p:sp>
       <p:pic>
         <p:nvPicPr>
@@ -3815,6 +3819,10 @@
             <a:srgbClr val="156D4F"/>
           </a:solidFill>
         </p:spPr>
+        <p:txBody>
+          <a:bodyPr/>
+          <a:p/>
+        </p:txBody>
       </p:sp>
       <p:pic>
         <p:nvPicPr>
@@ -3864,6 +3872,10 @@
             </a:srgbClr>
           </a:solidFill>
         </p:spPr>
+        <p:txBody>
+          <a:bodyPr/>
+          <a:p/>
+        </p:txBody>
       </p:sp>
       <p:sp>
         <p:nvSpPr>
@@ -4080,6 +4092,10 @@
             </a:outerShdw>
           </a:effectLst>
         </p:spPr>
+        <p:txBody>
+          <a:bodyPr/>
+          <a:p/>
+        </p:txBody>
       </p:sp>
       <p:sp>
         <p:nvSpPr>
@@ -4106,6 +4122,10 @@
             </a:outerShdw>
           </a:effectLst>
         </p:spPr>
+        <p:txBody>
+          <a:bodyPr/>
+          <a:p/>
+        </p:txBody>
       </p:sp>
       <p:pic>
         <p:nvPicPr>
@@ -4350,15 +4370,7 @@
               <a:buNone/>
             </a:pPr>
             <a:r>
-              <a:rPr lang="en-US" sz="1250" dirty="0">
-                <a:solidFill>
-                  <a:srgbClr val="364327"/>
-                </a:solidFill>
-                <a:latin typeface="Segoe UI" panose="020B0502040204020203" pitchFamily="34" charset="0"/>
-                <a:ea typeface="Segoe UI" panose="020B0502040204020203" pitchFamily="34" charset="-122"/>
-                <a:cs typeface="Segoe UI" panose="020B0502040204020203" pitchFamily="34" charset="-120"/>
-              </a:rPr>
-              <a:t>Data Persistence: Utilizes Hibernate ORM and Spring Data JPA to talk to PostgreSQL databases.</a:t>
+              <a:t>Data Persistence: Utilizes Spring Data MongoDB for document storage and 2dsphere GeoJSON spatial queries.</a:t>
             </a:r>
             <a:endParaRPr lang="en-US" sz="1250" dirty="0"/>
           </a:p>
@@ -4521,6 +4533,10 @@
             </a:outerShdw>
           </a:effectLst>
         </p:spPr>
+        <p:txBody>
+          <a:bodyPr/>
+          <a:p/>
+        </p:txBody>
       </p:sp>
       <p:sp>
         <p:nvSpPr>
@@ -4547,6 +4563,10 @@
             </a:outerShdw>
           </a:effectLst>
         </p:spPr>
+        <p:txBody>
+          <a:bodyPr/>
+          <a:p/>
+        </p:txBody>
       </p:sp>
       <p:pic>
         <p:nvPicPr>
@@ -4959,15 +4979,7 @@
               <a:buNone/>
             </a:pPr>
             <a:r>
-              <a:rPr lang="en-US" sz="1200" dirty="0">
-                <a:solidFill>
-                  <a:srgbClr val="364327"/>
-                </a:solidFill>
-                <a:latin typeface="Segoe UI" panose="020B0502040204020203" pitchFamily="34" charset="0"/>
-                <a:ea typeface="Segoe UI" panose="020B0502040204020203" pitchFamily="34" charset="-122"/>
-                <a:cs typeface="Segoe UI" panose="020B0502040204020203" pitchFamily="34" charset="-120"/>
-              </a:rPr>
-              <a:t>Gemini API Connector: Manages AI reasoning calls to translate outputs into text.</a:t>
+              <a:t>Groq LLM Gateway: Manages Groq API calls (Llama-3.3-70b) with local grounded fallback engine for offline reliability.</a:t>
             </a:r>
             <a:endParaRPr lang="en-US" sz="1200" dirty="0"/>
           </a:p>
@@ -5056,6 +5068,10 @@
             <a:srgbClr val="156D4F"/>
           </a:solidFill>
         </p:spPr>
+        <p:txBody>
+          <a:bodyPr/>
+          <a:p/>
+        </p:txBody>
       </p:sp>
       <p:pic>
         <p:nvPicPr>
@@ -5105,6 +5121,10 @@
             </a:srgbClr>
           </a:solidFill>
         </p:spPr>
+        <p:txBody>
+          <a:bodyPr/>
+          <a:p/>
+        </p:txBody>
       </p:sp>
       <p:sp>
         <p:nvSpPr>
@@ -6156,25 +6176,9 @@
                     <a:bodyPr/>
                     <a:lstStyle/>
                     <a:p>
-                      <a:pPr marL="0" indent="0">
-                        <a:buNone/>
-                      </a:pPr>
                       <a:r>
-                        <a:rPr lang="en-US" sz="1050" dirty="0">
-                          <a:solidFill>
-                            <a:srgbClr val="156D4F"/>
-                          </a:solidFill>
-                          <a:latin typeface="Segoe UI" panose="020B0502040204020203" pitchFamily="34" charset="0"/>
-                          <a:ea typeface="Segoe UI" panose="020B0502040204020203" pitchFamily="34" charset="-122"/>
-                          <a:cs typeface="Segoe UI" panose="020B0502040204020203" pitchFamily="34" charset="-120"/>
-                        </a:rPr>
                         <a:t>Explainable AI</a:t>
                       </a:r>
-                      <a:endParaRPr lang="en-US" sz="1050" dirty="0">
-                        <a:latin typeface="Segoe UI" panose="020B0502040204020203" pitchFamily="34" charset="0"/>
-                        <a:ea typeface="Segoe UI" panose="020B0502040204020203" pitchFamily="34" charset="0"/>
-                        <a:cs typeface="Segoe UI" panose="020B0502040204020203" pitchFamily="34" charset="0"/>
-                      </a:endParaRPr>
                     </a:p>
                   </a:txBody>
                   <a:tcPr anchor="ctr">
@@ -6221,25 +6225,9 @@
                     <a:bodyPr/>
                     <a:lstStyle/>
                     <a:p>
-                      <a:pPr marL="0" indent="0">
-                        <a:buNone/>
-                      </a:pPr>
                       <a:r>
-                        <a:rPr lang="en-US" sz="1050" dirty="0">
-                          <a:solidFill>
-                            <a:srgbClr val="156D4F"/>
-                          </a:solidFill>
-                          <a:latin typeface="Segoe UI" panose="020B0502040204020203" pitchFamily="34" charset="0"/>
-                          <a:ea typeface="Segoe UI" panose="020B0502040204020203" pitchFamily="34" charset="-122"/>
-                          <a:cs typeface="Segoe UI" panose="020B0502040204020203" pitchFamily="34" charset="-120"/>
-                        </a:rPr>
-                        <a:t>GenAI Prompt Reasoning</a:t>
+                        <a:t>Groq LLM Reasoning &amp; Fallback</a:t>
                       </a:r>
-                      <a:endParaRPr lang="en-US" sz="1050" dirty="0">
-                        <a:latin typeface="Segoe UI" panose="020B0502040204020203" pitchFamily="34" charset="0"/>
-                        <a:ea typeface="Segoe UI" panose="020B0502040204020203" pitchFamily="34" charset="0"/>
-                        <a:cs typeface="Segoe UI" panose="020B0502040204020203" pitchFamily="34" charset="0"/>
-                      </a:endParaRPr>
                     </a:p>
                   </a:txBody>
                   <a:tcPr anchor="ctr">
@@ -6286,25 +6274,9 @@
                     <a:bodyPr/>
                     <a:lstStyle/>
                     <a:p>
-                      <a:pPr marL="0" indent="0">
-                        <a:buNone/>
-                      </a:pPr>
                       <a:r>
-                        <a:rPr lang="en-US" sz="1050" dirty="0">
-                          <a:solidFill>
-                            <a:srgbClr val="156D4F"/>
-                          </a:solidFill>
-                          <a:latin typeface="Segoe UI" panose="020B0502040204020203" pitchFamily="34" charset="0"/>
-                          <a:ea typeface="Segoe UI" panose="020B0502040204020203" pitchFamily="34" charset="-122"/>
-                          <a:cs typeface="Segoe UI" panose="020B0502040204020203" pitchFamily="34" charset="-120"/>
-                        </a:rPr>
-                        <a:t>Interprets data metrics and translates raw scores into structured advice.</a:t>
+                        <a:t>Translates regression forecasts and OR-Tools MILP scores into structured decision explanations.</a:t>
                       </a:r>
-                      <a:endParaRPr lang="en-US" sz="1050" dirty="0">
-                        <a:latin typeface="Segoe UI" panose="020B0502040204020203" pitchFamily="34" charset="0"/>
-                        <a:ea typeface="Segoe UI" panose="020B0502040204020203" pitchFamily="34" charset="0"/>
-                        <a:cs typeface="Segoe UI" panose="020B0502040204020203" pitchFamily="34" charset="0"/>
-                      </a:endParaRPr>
                     </a:p>
                   </a:txBody>
                   <a:tcPr anchor="ctr">
@@ -6717,6 +6689,10 @@
             </a:outerShdw>
           </a:effectLst>
         </p:spPr>
+        <p:txBody>
+          <a:bodyPr/>
+          <a:p/>
+        </p:txBody>
       </p:sp>
       <p:pic>
         <p:nvPicPr>
@@ -7156,15 +7132,7 @@
               <a:buNone/>
             </a:pPr>
             <a:r>
-              <a:rPr lang="en-US" sz="1350" dirty="0">
-                <a:solidFill>
-                  <a:srgbClr val="364327"/>
-                </a:solidFill>
-                <a:latin typeface="Segoe UI" panose="020B0502040204020203" pitchFamily="34" charset="0"/>
-                <a:ea typeface="Segoe UI" panose="020B0502040204020203" pitchFamily="34" charset="-122"/>
-                <a:cs typeface="Segoe UI" panose="020B0502040204020203" pitchFamily="34" charset="-120"/>
-              </a:rPr>
-              <a:t>Redis cache setups managing fast updates of dashboard metrics.</a:t>
+              <a:t>MongoDB native indexes &amp; MinIO S3 proof storage managing fast metric retrieval.</a:t>
             </a:r>
             <a:endParaRPr lang="en-US" sz="1350" dirty="0"/>
           </a:p>
@@ -7188,6 +7156,10 @@
             <a:srgbClr val="156D4F"/>
           </a:solidFill>
         </p:spPr>
+        <p:txBody>
+          <a:bodyPr/>
+          <a:p/>
+        </p:txBody>
       </p:sp>
       <p:pic>
         <p:nvPicPr>
@@ -7237,6 +7209,10 @@
             </a:srgbClr>
           </a:solidFill>
         </p:spPr>
+        <p:txBody>
+          <a:bodyPr/>
+          <a:p/>
+        </p:txBody>
       </p:sp>
       <p:sp>
         <p:nvSpPr>
@@ -7491,6 +7467,10 @@
             </a:outerShdw>
           </a:effectLst>
         </p:spPr>
+        <p:txBody>
+          <a:bodyPr/>
+          <a:p/>
+        </p:txBody>
       </p:sp>
       <p:sp>
         <p:nvSpPr>
@@ -7512,6 +7492,10 @@
             <a:srgbClr val="C7C396"/>
           </a:solidFill>
         </p:spPr>
+        <p:txBody>
+          <a:bodyPr/>
+          <a:p/>
+        </p:txBody>
       </p:sp>
       <p:sp>
         <p:nvSpPr>
@@ -7531,6 +7515,10 @@
             <a:srgbClr val="C7C396"/>
           </a:solidFill>
         </p:spPr>
+        <p:txBody>
+          <a:bodyPr/>
+          <a:p/>
+        </p:txBody>
       </p:sp>
       <p:sp>
         <p:nvSpPr>
@@ -7595,6 +7583,10 @@
             </a:outerShdw>
           </a:effectLst>
         </p:spPr>
+        <p:txBody>
+          <a:bodyPr/>
+          <a:p/>
+        </p:txBody>
       </p:sp>
       <p:pic>
         <p:nvPicPr>
@@ -7685,15 +7677,7 @@
               <a:buNone/>
             </a:pPr>
             <a:r>
-              <a:rPr lang="en-US" sz="1200" dirty="0">
-                <a:solidFill>
-                  <a:srgbClr val="364327"/>
-                </a:solidFill>
-                <a:latin typeface="Bahnschrift Light SemiCondensed" panose="020B0502040204020203" charset="0"/>
-                <a:ea typeface="Segoe UI" panose="020B0502040204020203" pitchFamily="34" charset="-122"/>
-                <a:cs typeface="Bahnschrift Light SemiCondensed" panose="020B0502040204020203" charset="0"/>
-              </a:rPr>
-              <a:t>• Designed the layout, user interactions, and visual palettes.</a:t>
+              <a:t>• Designed Emerald Oasis UI/UX theme, React 18 2D Spatial Canvas, and Groq AI Omnibar.</a:t>
             </a:r>
             <a:endParaRPr lang="en-US" sz="1200" dirty="0">
               <a:latin typeface="Bahnschrift Light SemiCondensed" panose="020B0502040204020203" charset="0"/>
@@ -7708,15 +7692,7 @@
               <a:buNone/>
             </a:pPr>
             <a:r>
-              <a:rPr lang="en-US" sz="1200" dirty="0">
-                <a:solidFill>
-                  <a:srgbClr val="364327"/>
-                </a:solidFill>
-                <a:latin typeface="Bahnschrift Light SemiCondensed" panose="020B0502040204020203" charset="0"/>
-                <a:ea typeface="Segoe UI" panose="020B0502040204020203" pitchFamily="34" charset="-122"/>
-                <a:cs typeface="Bahnschrift Light SemiCondensed" panose="020B0502040204020203" charset="0"/>
-              </a:rPr>
-              <a:t>• Built React.js client screens, logs, and interactive dashboards.</a:t>
+              <a:t>• Built 12 workspace nodes, 3-mode view switcher (Canvas, Desktop, Mobile), and interactive charts.</a:t>
             </a:r>
             <a:endParaRPr lang="en-US" sz="1200" dirty="0">
               <a:latin typeface="Bahnschrift Light SemiCondensed" panose="020B0502040204020203" charset="0"/>
@@ -7802,6 +7778,10 @@
             </a:outerShdw>
           </a:effectLst>
         </p:spPr>
+        <p:txBody>
+          <a:bodyPr/>
+          <a:p/>
+        </p:txBody>
       </p:sp>
       <p:sp>
         <p:nvSpPr>
@@ -7823,6 +7803,10 @@
             <a:srgbClr val="C7C396"/>
           </a:solidFill>
         </p:spPr>
+        <p:txBody>
+          <a:bodyPr/>
+          <a:p/>
+        </p:txBody>
       </p:sp>
       <p:sp>
         <p:nvSpPr>
@@ -7842,6 +7826,10 @@
             <a:srgbClr val="C7C396"/>
           </a:solidFill>
         </p:spPr>
+        <p:txBody>
+          <a:bodyPr/>
+          <a:p/>
+        </p:txBody>
       </p:sp>
       <p:sp>
         <p:nvSpPr>
@@ -7906,6 +7894,10 @@
             </a:outerShdw>
           </a:effectLst>
         </p:spPr>
+        <p:txBody>
+          <a:bodyPr/>
+          <a:p/>
+        </p:txBody>
       </p:sp>
       <p:pic>
         <p:nvPicPr>
@@ -8019,15 +8011,7 @@
               <a:buNone/>
             </a:pPr>
             <a:r>
-              <a:rPr lang="en-US" sz="1200" dirty="0">
-                <a:solidFill>
-                  <a:srgbClr val="364327"/>
-                </a:solidFill>
-                <a:latin typeface="Bahnschrift Light SemiCondensed" panose="020B0502040204020203" charset="0"/>
-                <a:ea typeface="Segoe UI" panose="020B0502040204020203" pitchFamily="34" charset="-122"/>
-                <a:cs typeface="Bahnschrift Light SemiCondensed" panose="020B0502040204020203" charset="0"/>
-              </a:rPr>
-              <a:t>• Wrote unit tests and executed integration and end-to-end testing.</a:t>
+              <a:t>• Built JUnit 5 REST suite, Pytest ML suite, and 36-endpoint Node.js integration test suite.</a:t>
             </a:r>
             <a:endParaRPr lang="en-US" sz="1200" dirty="0">
               <a:latin typeface="Bahnschrift Light SemiCondensed" panose="020B0502040204020203" charset="0"/>
@@ -8065,15 +8049,7 @@
               <a:buNone/>
             </a:pPr>
             <a:r>
-              <a:rPr lang="en-US" sz="1200" dirty="0">
-                <a:solidFill>
-                  <a:srgbClr val="364327"/>
-                </a:solidFill>
-                <a:latin typeface="Bahnschrift Light SemiCondensed" panose="020B0502040204020203" charset="0"/>
-                <a:ea typeface="Segoe UI" panose="020B0502040204020203" pitchFamily="34" charset="-122"/>
-                <a:cs typeface="Bahnschrift Light SemiCondensed" panose="020B0502040204020203" charset="0"/>
-              </a:rPr>
-              <a:t>• Created automation scripts for test suites and validation mocks.</a:t>
+              <a:t>• Implemented Server-Sent Events (SSE) notification streaming and system telemetry monitoring.</a:t>
             </a:r>
             <a:endParaRPr lang="en-US" sz="1200" dirty="0">
               <a:solidFill>
@@ -8113,6 +8089,10 @@
             </a:outerShdw>
           </a:effectLst>
         </p:spPr>
+        <p:txBody>
+          <a:bodyPr/>
+          <a:p/>
+        </p:txBody>
       </p:sp>
       <p:sp>
         <p:nvSpPr>
@@ -8134,6 +8114,10 @@
             <a:srgbClr val="C7C396"/>
           </a:solidFill>
         </p:spPr>
+        <p:txBody>
+          <a:bodyPr/>
+          <a:p/>
+        </p:txBody>
       </p:sp>
       <p:sp>
         <p:nvSpPr>
@@ -8153,6 +8137,10 @@
             <a:srgbClr val="C7C396"/>
           </a:solidFill>
         </p:spPr>
+        <p:txBody>
+          <a:bodyPr/>
+          <a:p/>
+        </p:txBody>
       </p:sp>
       <p:sp>
         <p:nvSpPr>
@@ -8217,6 +8205,10 @@
             </a:outerShdw>
           </a:effectLst>
         </p:spPr>
+        <p:txBody>
+          <a:bodyPr/>
+          <a:p/>
+        </p:txBody>
       </p:sp>
       <p:pic>
         <p:nvPicPr>
@@ -8307,15 +8299,7 @@
               <a:buNone/>
             </a:pPr>
             <a:r>
-              <a:rPr lang="en-US" sz="1200" dirty="0">
-                <a:solidFill>
-                  <a:srgbClr val="364327"/>
-                </a:solidFill>
-                <a:latin typeface="Bahnschrift Light SemiCondensed" panose="020B0502040204020203" charset="0"/>
-                <a:ea typeface="Segoe UI" panose="020B0502040204020203" pitchFamily="34" charset="-122"/>
-                <a:cs typeface="Bahnschrift Light SemiCondensed" panose="020B0502040204020203" charset="0"/>
-              </a:rPr>
-              <a:t>• Architected Spring Boot gateway services and PostgreSQL schemas.</a:t>
+              <a:t>• Architected Spring Boot 3.2 REST services and MongoDB 2dsphere GeoJSON schemas.</a:t>
             </a:r>
             <a:endParaRPr lang="en-US" sz="1200" dirty="0">
               <a:latin typeface="Bahnschrift Light SemiCondensed" panose="020B0502040204020203" charset="0"/>
@@ -8353,15 +8337,7 @@
               <a:buNone/>
             </a:pPr>
             <a:r>
-              <a:rPr lang="en-US" sz="1200" dirty="0">
-                <a:solidFill>
-                  <a:srgbClr val="364327"/>
-                </a:solidFill>
-                <a:latin typeface="Bahnschrift Light SemiCondensed" panose="020B0502040204020203" charset="0"/>
-                <a:ea typeface="Segoe UI" panose="020B0502040204020203" pitchFamily="34" charset="-122"/>
-                <a:cs typeface="Bahnschrift Light SemiCondensed" panose="020B0502040204020203" charset="0"/>
-              </a:rPr>
-              <a:t>• Configured Google OR-Tools solvers and Postgres/PostGIS databases.</a:t>
+              <a:t>• Configured Google OR-Tools MILP solver, FastAPI XGBoost pipeline, and Groq AI LLM Gateway.</a:t>
             </a:r>
             <a:endParaRPr lang="en-US" sz="1200" dirty="0">
               <a:latin typeface="Bahnschrift Light SemiCondensed" panose="020B0502040204020203" charset="0"/>
@@ -8424,6 +8400,10 @@
             </a:outerShdw>
           </a:effectLst>
         </p:spPr>
+        <p:txBody>
+          <a:bodyPr/>
+          <a:p/>
+        </p:txBody>
       </p:sp>
       <p:sp>
         <p:nvSpPr>
@@ -8445,6 +8425,10 @@
             <a:srgbClr val="C7C396"/>
           </a:solidFill>
         </p:spPr>
+        <p:txBody>
+          <a:bodyPr/>
+          <a:p/>
+        </p:txBody>
       </p:sp>
       <p:sp>
         <p:nvSpPr>
@@ -8464,6 +8448,10 @@
             <a:srgbClr val="C7C396"/>
           </a:solidFill>
         </p:spPr>
+        <p:txBody>
+          <a:bodyPr/>
+          <a:p/>
+        </p:txBody>
       </p:sp>
       <p:sp>
         <p:nvSpPr>
@@ -8528,6 +8516,10 @@
             </a:outerShdw>
           </a:effectLst>
         </p:spPr>
+        <p:txBody>
+          <a:bodyPr/>
+          <a:p/>
+        </p:txBody>
       </p:sp>
       <p:pic>
         <p:nvPicPr>
@@ -8618,15 +8610,7 @@
               <a:buNone/>
             </a:pPr>
             <a:r>
-              <a:rPr lang="en-US" sz="1200" dirty="0">
-                <a:solidFill>
-                  <a:srgbClr val="364327"/>
-                </a:solidFill>
-                <a:latin typeface="Bahnschrift Light SemiCondensed" panose="020B0502040204020203" charset="0"/>
-                <a:ea typeface="Segoe UI" panose="020B0502040204020203" pitchFamily="34" charset="-122"/>
-                <a:cs typeface="Bahnschrift Light SemiCondensed" panose="020B0502040204020203" charset="0"/>
-              </a:rPr>
-              <a:t>• Managed frontend-backend integration and resolved connection bottlenecks.</a:t>
+              <a:t>• Built PowerShell multi-service system launcher (run-phase11-system.ps1) and PDF generator.</a:t>
             </a:r>
             <a:endParaRPr lang="en-US" sz="1200" dirty="0">
               <a:latin typeface="Bahnschrift Light SemiCondensed" panose="020B0502040204020203" charset="0"/>
@@ -8641,15 +8625,7 @@
               <a:buNone/>
             </a:pPr>
             <a:r>
-              <a:rPr lang="en-US" sz="1200" dirty="0">
-                <a:solidFill>
-                  <a:srgbClr val="364327"/>
-                </a:solidFill>
-                <a:latin typeface="Bahnschrift Light SemiCondensed" panose="020B0502040204020203" charset="0"/>
-                <a:ea typeface="Segoe UI" panose="020B0502040204020203" pitchFamily="34" charset="-122"/>
-                <a:cs typeface="Bahnschrift Light SemiCondensed" panose="020B0502040204020203" charset="0"/>
-              </a:rPr>
-              <a:t>• Supported AI/ML pipeline deployments and prompt configurations.</a:t>
+              <a:t>• Configured MinIO S3 object storage and Tesseract OCR utility bill parsing.</a:t>
             </a:r>
             <a:endParaRPr lang="en-US" sz="1200" dirty="0">
               <a:latin typeface="Bahnschrift Light SemiCondensed" panose="020B0502040204020203" charset="0"/>
@@ -8764,6 +8740,10 @@
             <a:srgbClr val="156D4F"/>
           </a:solidFill>
         </p:spPr>
+        <p:txBody>
+          <a:bodyPr/>
+          <a:p/>
+        </p:txBody>
       </p:sp>
       <p:pic>
         <p:nvPicPr>
@@ -8813,6 +8793,10 @@
             </a:srgbClr>
           </a:solidFill>
         </p:spPr>
+        <p:txBody>
+          <a:bodyPr/>
+          <a:p/>
+        </p:txBody>
       </p:sp>
       <p:sp>
         <p:nvSpPr>
@@ -8988,15 +8972,7 @@
               <a:buNone/>
             </a:pPr>
             <a:r>
-              <a:rPr lang="en-US" sz="2800" b="1" dirty="0">
-                <a:solidFill>
-                  <a:srgbClr val="156D4F"/>
-                </a:solidFill>
-                <a:latin typeface="Georgia" panose="02040502050405020303" pitchFamily="34" charset="0"/>
-                <a:ea typeface="Georgia" panose="02040502050405020303" pitchFamily="34" charset="-122"/>
-                <a:cs typeface="Georgia" panose="02040502050405020303" pitchFamily="34" charset="-120"/>
-              </a:rPr>
-              <a:t>Prototype Roadmap</a:t>
+              <a:t>Full System Execution Roadmap — ALL PHASES COMPLETED ✅</a:t>
             </a:r>
             <a:endParaRPr lang="en-US" sz="2800" dirty="0"/>
           </a:p>
@@ -9026,15 +9002,7 @@
               <a:buNone/>
             </a:pPr>
             <a:r>
-              <a:rPr lang="en-US" sz="1250" dirty="0">
-                <a:solidFill>
-                  <a:srgbClr val="156D4F"/>
-                </a:solidFill>
-                <a:latin typeface="Segoe UI" panose="020B0502040204020203" pitchFamily="34" charset="0"/>
-                <a:ea typeface="Segoe UI" panose="020B0502040204020203" pitchFamily="34" charset="-122"/>
-                <a:cs typeface="Segoe UI" panose="020B0502040204020203" pitchFamily="34" charset="-120"/>
-              </a:rPr>
-              <a:t>The implementation roadmap maps 6 weeks of prototype execution across four distinct milestones.</a:t>
+              <a:t>The system development roadmap maps 7 complete phases from ideation to production verification.</a:t>
             </a:r>
             <a:endParaRPr lang="en-US" sz="1250" dirty="0"/>
           </a:p>
@@ -9067,6 +9035,10 @@
             </a:outerShdw>
           </a:effectLst>
         </p:spPr>
+        <p:txBody>
+          <a:bodyPr/>
+          <a:p/>
+        </p:txBody>
       </p:sp>
       <p:sp>
         <p:nvSpPr>
@@ -9093,6 +9065,10 @@
             </a:outerShdw>
           </a:effectLst>
         </p:spPr>
+        <p:txBody>
+          <a:bodyPr/>
+          <a:p/>
+        </p:txBody>
       </p:sp>
       <p:pic>
         <p:nvPicPr>
@@ -9142,15 +9118,7 @@
               <a:buNone/>
             </a:pPr>
             <a:r>
-              <a:rPr lang="en-US" sz="1600" b="1" dirty="0">
-                <a:solidFill>
-                  <a:srgbClr val="156D4F"/>
-                </a:solidFill>
-                <a:latin typeface="Segoe UI" panose="020B0502040204020203" pitchFamily="34" charset="0"/>
-                <a:ea typeface="Segoe UI" panose="020B0502040204020203" pitchFamily="34" charset="-122"/>
-                <a:cs typeface="Segoe UI" panose="020B0502040204020203" pitchFamily="34" charset="-120"/>
-              </a:rPr>
-              <a:t>Phase 1: DB &amp; API Skeleton (W1-2)</a:t>
+              <a:t>Phase 1 &amp; 2: Client Spatial UI &amp; Spring Boot Backend — COMPLETED ✅</a:t>
             </a:r>
             <a:endParaRPr lang="en-US" sz="1600" dirty="0"/>
           </a:p>
@@ -9183,15 +9151,7 @@
               <a:buNone/>
             </a:pPr>
             <a:r>
-              <a:rPr lang="en-US" sz="1350" dirty="0">
-                <a:solidFill>
-                  <a:srgbClr val="364327"/>
-                </a:solidFill>
-                <a:latin typeface="Segoe UI" panose="020B0502040204020203" pitchFamily="34" charset="0"/>
-                <a:ea typeface="Segoe UI" panose="020B0502040204020203" pitchFamily="34" charset="-122"/>
-                <a:cs typeface="Segoe UI" panose="020B0502040204020203" pitchFamily="34" charset="-120"/>
-              </a:rPr>
-              <a:t>Initialize Spring Boot API gateway, write PostgreSQL relational and spatial tables, configure secure token login, and set up Redis caching layers.</a:t>
+              <a:t>React 18 Spatial Canvas shell, Emerald Oasis theme, Spring Boot 3.2 REST services, JWT auth, and MongoDB schemas.</a:t>
             </a:r>
             <a:endParaRPr lang="en-US" sz="1350" dirty="0"/>
           </a:p>
@@ -9224,6 +9184,10 @@
             </a:outerShdw>
           </a:effectLst>
         </p:spPr>
+        <p:txBody>
+          <a:bodyPr/>
+          <a:p/>
+        </p:txBody>
       </p:sp>
       <p:sp>
         <p:nvSpPr>
@@ -9250,6 +9214,10 @@
             </a:outerShdw>
           </a:effectLst>
         </p:spPr>
+        <p:txBody>
+          <a:bodyPr/>
+          <a:p/>
+        </p:txBody>
       </p:sp>
       <p:pic>
         <p:nvPicPr>
@@ -9299,15 +9267,7 @@
               <a:buNone/>
             </a:pPr>
             <a:r>
-              <a:rPr lang="en-US" sz="1600" b="1" dirty="0">
-                <a:solidFill>
-                  <a:srgbClr val="156D4F"/>
-                </a:solidFill>
-                <a:latin typeface="Segoe UI" panose="020B0502040204020203" pitchFamily="34" charset="0"/>
-                <a:ea typeface="Segoe UI" panose="020B0502040204020203" pitchFamily="34" charset="-122"/>
-                <a:cs typeface="Segoe UI" panose="020B0502040204020203" pitchFamily="34" charset="-120"/>
-              </a:rPr>
-              <a:t>Phase 2: ML &amp; Data (W3-4)</a:t>
+              <a:t>Phase 3 &amp; 4: ML Forecasting, MILP Solver &amp; GIS Tier — COMPLETED ✅</a:t>
             </a:r>
             <a:endParaRPr lang="en-US" sz="1600" dirty="0"/>
           </a:p>
@@ -9340,15 +9300,7 @@
               <a:buNone/>
             </a:pPr>
             <a:r>
-              <a:rPr lang="en-US" sz="1350" dirty="0">
-                <a:solidFill>
-                  <a:srgbClr val="364327"/>
-                </a:solidFill>
-                <a:latin typeface="Segoe UI" panose="020B0502040204020203" pitchFamily="34" charset="0"/>
-                <a:ea typeface="Segoe UI" panose="020B0502040204020203" pitchFamily="34" charset="-122"/>
-                <a:cs typeface="Segoe UI" panose="020B0502040204020203" pitchFamily="34" charset="-120"/>
-              </a:rPr>
-              <a:t>Integrate Python FastAPI ML container, train XGBoost models on energy and carbon datasets, and write Leaflet map overlays with geocoding tools.</a:t>
+              <a:t>FastAPI XGBoost 30-day forecaster, IsolationForest anomaly engine, Google OR-Tools MILP solver, MongoDB 2dsphere geofencing, MinIO S3 OCR.</a:t>
             </a:r>
             <a:endParaRPr lang="en-US" sz="1350" dirty="0"/>
           </a:p>
@@ -9381,6 +9333,10 @@
             </a:outerShdw>
           </a:effectLst>
         </p:spPr>
+        <p:txBody>
+          <a:bodyPr/>
+          <a:p/>
+        </p:txBody>
       </p:sp>
       <p:sp>
         <p:nvSpPr>
@@ -9407,6 +9363,10 @@
             </a:outerShdw>
           </a:effectLst>
         </p:spPr>
+        <p:txBody>
+          <a:bodyPr/>
+          <a:p/>
+        </p:txBody>
       </p:sp>
       <p:pic>
         <p:nvPicPr>
@@ -9456,15 +9416,7 @@
               <a:buNone/>
             </a:pPr>
             <a:r>
-              <a:rPr lang="en-US" sz="1600" b="1" dirty="0">
-                <a:solidFill>
-                  <a:srgbClr val="156D4F"/>
-                </a:solidFill>
-                <a:latin typeface="Segoe UI" panose="020B0502040204020203" pitchFamily="34" charset="0"/>
-                <a:ea typeface="Segoe UI" panose="020B0502040204020203" pitchFamily="34" charset="-122"/>
-                <a:cs typeface="Segoe UI" panose="020B0502040204020203" pitchFamily="34" charset="-120"/>
-              </a:rPr>
-              <a:t>Phase 3: Digital Twin &amp; Optimization (W5)</a:t>
+              <a:t>Phase 5 &amp; 6: Groq LLM Gateway, SSE Stream &amp; Telemetry — COMPLETED ✅</a:t>
             </a:r>
             <a:endParaRPr lang="en-US" sz="1600" dirty="0"/>
           </a:p>
@@ -9497,15 +9449,7 @@
               <a:buNone/>
             </a:pPr>
             <a:r>
-              <a:rPr lang="en-US" sz="1350" dirty="0">
-                <a:solidFill>
-                  <a:srgbClr val="364327"/>
-                </a:solidFill>
-                <a:latin typeface="Segoe UI" panose="020B0502040204020203" pitchFamily="34" charset="0"/>
-                <a:ea typeface="Segoe UI" panose="020B0502040204020203" pitchFamily="34" charset="-122"/>
-                <a:cs typeface="Segoe UI" panose="020B0502040204020203" pitchFamily="34" charset="-120"/>
-              </a:rPr>
-              <a:t>Assemble the Household Digital Twin simulator, code Google OR-Tools multi-objective optimization solvers, and write comparative scenario rules.</a:t>
+              <a:t>Groq AI Gateway (Llama-3.3-70b) with local grounded fallback engine, SSE real-time notifications, system health telemetry.</a:t>
             </a:r>
             <a:endParaRPr lang="en-US" sz="1350" dirty="0"/>
           </a:p>
@@ -9538,6 +9482,10 @@
             </a:outerShdw>
           </a:effectLst>
         </p:spPr>
+        <p:txBody>
+          <a:bodyPr/>
+          <a:p/>
+        </p:txBody>
       </p:sp>
       <p:sp>
         <p:nvSpPr>
@@ -9564,6 +9512,10 @@
             </a:outerShdw>
           </a:effectLst>
         </p:spPr>
+        <p:txBody>
+          <a:bodyPr/>
+          <a:p/>
+        </p:txBody>
       </p:sp>
       <p:pic>
         <p:nvPicPr>
@@ -9613,15 +9565,7 @@
               <a:buNone/>
             </a:pPr>
             <a:r>
-              <a:rPr lang="en-US" sz="1600" b="1" dirty="0">
-                <a:solidFill>
-                  <a:srgbClr val="156D4F"/>
-                </a:solidFill>
-                <a:latin typeface="Segoe UI" panose="020B0502040204020203" pitchFamily="34" charset="0"/>
-                <a:ea typeface="Segoe UI" panose="020B0502040204020203" pitchFamily="34" charset="-122"/>
-                <a:cs typeface="Segoe UI" panose="020B0502040204020203" pitchFamily="34" charset="-120"/>
-              </a:rPr>
-              <a:t>Phase 4: AI Assistant &amp; Launch (W6)</a:t>
+              <a:t>Phase 7: Automated Verification &amp; Production Release — COMPLETED ✅</a:t>
             </a:r>
             <a:endParaRPr lang="en-US" sz="1600" dirty="0"/>
           </a:p>
@@ -9654,15 +9598,7 @@
               <a:buNone/>
             </a:pPr>
             <a:r>
-              <a:rPr lang="en-US" sz="1350" dirty="0">
-                <a:solidFill>
-                  <a:srgbClr val="364327"/>
-                </a:solidFill>
-                <a:latin typeface="Segoe UI" panose="020B0502040204020203" pitchFamily="34" charset="0"/>
-                <a:ea typeface="Segoe UI" panose="020B0502040204020203" pitchFamily="34" charset="-122"/>
-                <a:cs typeface="Segoe UI" panose="020B0502040204020203" pitchFamily="34" charset="-120"/>
-              </a:rPr>
-              <a:t>Connect Gemini API to explain scores and write reports, add activity verification modules, execute benchmarks, and deploy on Railway.</a:t>
+              <a:t>JUnit 5 + Pytest + 36-endpoint integration test suite, PowerShell system launcher script (run-phase11-system.ps1).</a:t>
             </a:r>
             <a:endParaRPr lang="en-US" sz="1350" dirty="0"/>
           </a:p>
@@ -9694,6 +9630,10 @@
             <a:prstDash val="solid"/>
           </a:ln>
         </p:spPr>
+        <p:txBody>
+          <a:bodyPr/>
+          <a:p/>
+        </p:txBody>
       </p:sp>
       <p:pic>
         <p:nvPicPr>
@@ -9775,6 +9715,10 @@
             <a:srgbClr val="156D4F"/>
           </a:solidFill>
         </p:spPr>
+        <p:txBody>
+          <a:bodyPr/>
+          <a:p/>
+        </p:txBody>
       </p:sp>
       <p:pic>
         <p:nvPicPr>
@@ -9824,6 +9768,10 @@
             </a:srgbClr>
           </a:solidFill>
         </p:spPr>
+        <p:txBody>
+          <a:bodyPr/>
+          <a:p/>
+        </p:txBody>
       </p:sp>
       <p:sp>
         <p:nvSpPr>
@@ -10078,6 +10026,10 @@
             </a:outerShdw>
           </a:effectLst>
         </p:spPr>
+        <p:txBody>
+          <a:bodyPr/>
+          <a:p/>
+        </p:txBody>
       </p:sp>
       <p:sp>
         <p:nvSpPr>
@@ -10104,6 +10056,10 @@
             </a:outerShdw>
           </a:effectLst>
         </p:spPr>
+        <p:txBody>
+          <a:bodyPr/>
+          <a:p/>
+        </p:txBody>
       </p:sp>
       <p:pic>
         <p:nvPicPr>
@@ -10519,6 +10475,10 @@
             </a:outerShdw>
           </a:effectLst>
         </p:spPr>
+        <p:txBody>
+          <a:bodyPr/>
+          <a:p/>
+        </p:txBody>
       </p:sp>
       <p:sp>
         <p:nvSpPr>
@@ -10545,6 +10505,10 @@
             </a:outerShdw>
           </a:effectLst>
         </p:spPr>
+        <p:txBody>
+          <a:bodyPr/>
+          <a:p/>
+        </p:txBody>
       </p:sp>
       <p:pic>
         <p:nvPicPr>
@@ -11054,6 +11018,10 @@
             <a:srgbClr val="156D4F"/>
           </a:solidFill>
         </p:spPr>
+        <p:txBody>
+          <a:bodyPr/>
+          <a:p/>
+        </p:txBody>
       </p:sp>
       <p:pic>
         <p:nvPicPr>
@@ -11103,6 +11071,10 @@
             </a:srgbClr>
           </a:solidFill>
         </p:spPr>
+        <p:txBody>
+          <a:bodyPr/>
+          <a:p/>
+        </p:txBody>
       </p:sp>
       <p:sp>
         <p:nvSpPr>
@@ -11236,6 +11208,10 @@
             </a:srgbClr>
           </a:solidFill>
         </p:spPr>
+        <p:txBody>
+          <a:bodyPr/>
+          <a:p/>
+        </p:txBody>
       </p:sp>
       <p:sp>
         <p:nvSpPr>
@@ -11340,6 +11316,10 @@
             </a:outerShdw>
           </a:effectLst>
         </p:spPr>
+        <p:txBody>
+          <a:bodyPr/>
+          <a:p/>
+        </p:txBody>
       </p:sp>
       <p:sp>
         <p:nvSpPr>
@@ -11382,15 +11362,7 @@
               <a:buNone/>
             </a:pPr>
             <a:r>
-              <a:rPr lang="en-US" sz="1300" b="1" dirty="0">
-                <a:solidFill>
-                  <a:srgbClr val="364327"/>
-                </a:solidFill>
-                <a:latin typeface="Segoe UI" panose="020B0502040204020203" pitchFamily="34" charset="0"/>
-                <a:ea typeface="Segoe UI" panose="020B0502040204020203" pitchFamily="34" charset="-122"/>
-                <a:cs typeface="Segoe UI" panose="020B0502040204020203" pitchFamily="34" charset="-120"/>
-              </a:rPr>
-              <a:t>PROTOTYPING &amp; R&amp;D</a:t>
+              <a:t>PRODUCTION RELEASE &amp; DEPLOYMENT</a:t>
             </a:r>
             <a:endParaRPr lang="en-US" sz="1300" dirty="0"/>
           </a:p>
@@ -11423,15 +11395,7 @@
               <a:buNone/>
             </a:pPr>
             <a:r>
-              <a:rPr lang="en-US" sz="1350" dirty="0">
-                <a:solidFill>
-                  <a:srgbClr val="FFFFFF"/>
-                </a:solidFill>
-                <a:latin typeface="Segoe UI" panose="020B0502040204020203" pitchFamily="34" charset="0"/>
-                <a:ea typeface="Segoe UI" panose="020B0502040204020203" pitchFamily="34" charset="-122"/>
-                <a:cs typeface="Segoe UI" panose="020B0502040204020203" pitchFamily="34" charset="-120"/>
-              </a:rPr>
-              <a:t>The EcoSphere Intelligent Environmental Decision Support proposal is highly viable and approved for implementation. It shifts the paradigm of final-year sustainability projects from static tracking to active, predictive analytics and optimization. Built on a modular and mature stack (React, Spring Boot, FastAPI, PostgreSQL, and Google OR-Tools), it offers solid features like behavior learning, time-series forecasting, multi-resource solving, and verified activity loops.</a:t>
+              <a:t>The EcoSphere (VerdantIQ) Intelligent Environmental Decision Support Platform has been fully developed, integrated, and verified across all 36 microservice endpoints. Built on a modular, enterprise stack (React 18 Spatial Canvas, Spring Boot 3.2, MongoDB 2dsphere, FastAPI, Google OR-Tools MILP, Groq AI LLM Gateway, and MinIO S3 OCR), it successfully delivers behavior learning, time-series forecasting, multi-resource solving, and verified activity loops.</a:t>
             </a:r>
             <a:endParaRPr lang="en-US" sz="1350" dirty="0"/>
           </a:p>
@@ -11463,6 +11427,10 @@
             <a:prstDash val="solid"/>
           </a:ln>
         </p:spPr>
+        <p:txBody>
+          <a:bodyPr/>
+          <a:p/>
+        </p:txBody>
       </p:sp>
       <p:sp>
         <p:nvSpPr>
@@ -11489,6 +11457,10 @@
             </a:outerShdw>
           </a:effectLst>
         </p:spPr>
+        <p:txBody>
+          <a:bodyPr/>
+          <a:p/>
+        </p:txBody>
       </p:sp>
       <p:pic>
         <p:nvPicPr>
@@ -11651,15 +11623,7 @@
               <a:buNone/>
             </a:pPr>
             <a:r>
-              <a:rPr lang="en-US" sz="1350" dirty="0">
-                <a:solidFill>
-                  <a:srgbClr val="FFFFFF"/>
-                </a:solidFill>
-                <a:latin typeface="Segoe UI" panose="020B0502040204020203" pitchFamily="34" charset="0"/>
-                <a:ea typeface="Segoe UI" panose="020B0502040204020203" pitchFamily="34" charset="-122"/>
-                <a:cs typeface="Segoe UI" panose="020B0502040204020203" pitchFamily="34" charset="-120"/>
-              </a:rPr>
-              <a:t>✓  Proven PostgreSQL relational schema</a:t>
+              <a:t>✓  Proven MongoDB 2dsphere GeoJSON spatial database</a:t>
             </a:r>
             <a:endParaRPr lang="en-US" sz="1350" dirty="0"/>
           </a:p>
@@ -11691,6 +11655,10 @@
             <a:prstDash val="solid"/>
           </a:ln>
         </p:spPr>
+        <p:txBody>
+          <a:bodyPr/>
+          <a:p/>
+        </p:txBody>
       </p:sp>
       <p:sp>
         <p:nvSpPr>
@@ -11717,6 +11685,10 @@
             </a:outerShdw>
           </a:effectLst>
         </p:spPr>
+        <p:txBody>
+          <a:bodyPr/>
+          <a:p/>
+        </p:txBody>
       </p:sp>
       <p:pic>
         <p:nvPicPr>
@@ -11856,15 +11828,7 @@
               <a:buNone/>
             </a:pPr>
             <a:r>
-              <a:rPr lang="en-US" sz="1350" dirty="0">
-                <a:solidFill>
-                  <a:srgbClr val="FFFFFF"/>
-                </a:solidFill>
-                <a:latin typeface="Segoe UI" panose="020B0502040204020203" pitchFamily="34" charset="0"/>
-                <a:ea typeface="Segoe UI" panose="020B0502040204020203" pitchFamily="34" charset="-122"/>
-                <a:cs typeface="Segoe UI" panose="020B0502040204020203" pitchFamily="34" charset="-120"/>
-              </a:rPr>
-              <a:t>✓  Gemini explanation generation prompts</a:t>
+              <a:t>✓  Groq LLM Gateway &amp; local grounded fallback engine</a:t>
             </a:r>
             <a:endParaRPr lang="en-US" sz="1350" dirty="0"/>
           </a:p>
@@ -11919,6 +11883,10 @@
             <a:prstDash val="solid"/>
           </a:ln>
         </p:spPr>
+        <p:txBody>
+          <a:bodyPr/>
+          <a:p/>
+        </p:txBody>
       </p:sp>
       <p:sp>
         <p:nvSpPr>
@@ -11945,6 +11913,10 @@
             </a:outerShdw>
           </a:effectLst>
         </p:spPr>
+        <p:txBody>
+          <a:bodyPr/>
+          <a:p/>
+        </p:txBody>
       </p:sp>
       <p:pic>
         <p:nvPicPr>
@@ -12139,6 +12111,10 @@
             <a:srgbClr val="156D4F"/>
           </a:solidFill>
         </p:spPr>
+        <p:txBody>
+          <a:bodyPr/>
+          <a:p/>
+        </p:txBody>
       </p:sp>
       <p:pic>
         <p:nvPicPr>
@@ -12301,6 +12277,10 @@
             </a:srgbClr>
           </a:solidFill>
         </p:spPr>
+        <p:txBody>
+          <a:bodyPr/>
+          <a:p/>
+        </p:txBody>
       </p:sp>
       <p:sp>
         <p:nvSpPr>
@@ -12327,6 +12307,10 @@
             </a:outerShdw>
           </a:effectLst>
         </p:spPr>
+        <p:txBody>
+          <a:bodyPr/>
+          <a:p/>
+        </p:txBody>
       </p:sp>
       <p:pic>
         <p:nvPicPr>
@@ -12414,16 +12398,7 @@
               <a:buNone/>
             </a:pPr>
             <a:r>
-              <a:rPr lang="en-US" sz="2600" b="1" dirty="0">
-                <a:solidFill>
-                  <a:srgbClr val="5BDCBB"/>
-                </a:solidFill>
-                <a:latin typeface="Georgia" panose="02040502050405020303" pitchFamily="34" charset="0"/>
-                <a:ea typeface="Georgia" panose="02040502050405020303" pitchFamily="34" charset="-122"/>
-                <a:cs typeface="Georgia" panose="02040502050405020303" pitchFamily="34" charset="-120"/>
-                <a:hlinkClick r:id="rId2" tooltip="" action="ppaction://hlinkfile"/>
-              </a:rPr>
-              <a:t>EcoSphere moves to Phase 1 — Implementation</a:t>
+              <a:t>EcoSphere (VerdantIQ) System — Fully Completed &amp; Verified ✅</a:t>
             </a:r>
             <a:endParaRPr lang="en-US" sz="2600" dirty="0"/>
           </a:p>
@@ -12453,15 +12428,7 @@
               <a:buNone/>
             </a:pPr>
             <a:r>
-              <a:rPr lang="en-US" sz="1300" dirty="0">
-                <a:solidFill>
-                  <a:srgbClr val="FFFFFF"/>
-                </a:solidFill>
-                <a:latin typeface="Segoe UI" panose="020B0502040204020203" pitchFamily="34" charset="0"/>
-                <a:ea typeface="Segoe UI" panose="020B0502040204020203" pitchFamily="34" charset="-122"/>
-                <a:cs typeface="Segoe UI" panose="020B0502040204020203" pitchFamily="34" charset="-120"/>
-              </a:rPr>
-              <a:t>Focus: DB Design &amp; Core API Gateways  |  Target: Predictive Environmental Decisions  |  Next Steps: Spring Boot Setup &amp; FastAPI Container Configurations</a:t>
+              <a:t>Status: 100% Endpoint Verification | Stack: React Spatial UI, Spring Boot 3.2, FastAPI, MongoDB, MinIO S3, Groq AI | Automated PowerShell System Launcher Ready</a:t>
             </a:r>
             <a:endParaRPr lang="en-US" sz="1300" dirty="0"/>
           </a:p>
@@ -12489,6 +12456,10 @@
             <a:prstDash val="solid"/>
           </a:ln>
         </p:spPr>
+        <p:txBody>
+          <a:bodyPr/>
+          <a:p/>
+        </p:txBody>
       </p:sp>
       <p:sp>
         <p:nvSpPr>
@@ -12546,6 +12517,10 @@
             <a:srgbClr val="156D4F"/>
           </a:solidFill>
         </p:spPr>
+        <p:txBody>
+          <a:bodyPr/>
+          <a:p/>
+        </p:txBody>
       </p:sp>
       <p:pic>
         <p:nvPicPr>
@@ -12667,6 +12642,10 @@
             </a:srgbClr>
           </a:solidFill>
         </p:spPr>
+        <p:txBody>
+          <a:bodyPr/>
+          <a:p/>
+        </p:txBody>
       </p:sp>
       <p:sp>
         <p:nvSpPr>
@@ -12811,6 +12790,10 @@
             <a:prstDash val="solid"/>
           </a:ln>
         </p:spPr>
+        <p:txBody>
+          <a:bodyPr/>
+          <a:p/>
+        </p:txBody>
       </p:sp>
       <p:pic>
         <p:nvPicPr>
@@ -12900,6 +12883,10 @@
             <a:prstDash val="solid"/>
           </a:ln>
         </p:spPr>
+        <p:txBody>
+          <a:bodyPr/>
+          <a:p/>
+        </p:txBody>
       </p:sp>
       <p:pic>
         <p:nvPicPr>
@@ -12989,6 +12976,10 @@
             <a:prstDash val="solid"/>
           </a:ln>
         </p:spPr>
+        <p:txBody>
+          <a:bodyPr/>
+          <a:p/>
+        </p:txBody>
       </p:sp>
       <p:pic>
         <p:nvPicPr>
@@ -13081,6 +13072,10 @@
             </a:outerShdw>
           </a:effectLst>
         </p:spPr>
+        <p:txBody>
+          <a:bodyPr/>
+          <a:p/>
+        </p:txBody>
       </p:sp>
       <p:sp>
         <p:nvSpPr>
@@ -14361,6 +14356,10 @@
             </a:outerShdw>
           </a:effectLst>
         </p:spPr>
+        <p:txBody>
+          <a:bodyPr/>
+          <a:p/>
+        </p:txBody>
       </p:sp>
       <p:sp>
         <p:nvSpPr>
@@ -14387,6 +14386,10 @@
             </a:outerShdw>
           </a:effectLst>
         </p:spPr>
+        <p:txBody>
+          <a:bodyPr/>
+          <a:p/>
+        </p:txBody>
       </p:sp>
       <p:pic>
         <p:nvPicPr>
@@ -14567,6 +14570,10 @@
             </a:outerShdw>
           </a:effectLst>
         </p:spPr>
+        <p:txBody>
+          <a:bodyPr/>
+          <a:p/>
+        </p:txBody>
       </p:sp>
       <p:sp>
         <p:nvSpPr>
@@ -14593,6 +14600,10 @@
             </a:outerShdw>
           </a:effectLst>
         </p:spPr>
+        <p:txBody>
+          <a:bodyPr/>
+          <a:p/>
+        </p:txBody>
       </p:sp>
       <p:pic>
         <p:nvPicPr>
@@ -14773,6 +14784,10 @@
             </a:outerShdw>
           </a:effectLst>
         </p:spPr>
+        <p:txBody>
+          <a:bodyPr/>
+          <a:p/>
+        </p:txBody>
       </p:sp>
       <p:sp>
         <p:nvSpPr>
@@ -14799,6 +14814,10 @@
             </a:outerShdw>
           </a:effectLst>
         </p:spPr>
+        <p:txBody>
+          <a:bodyPr/>
+          <a:p/>
+        </p:txBody>
       </p:sp>
       <p:pic>
         <p:nvPicPr>
@@ -14979,6 +14998,10 @@
             </a:outerShdw>
           </a:effectLst>
         </p:spPr>
+        <p:txBody>
+          <a:bodyPr/>
+          <a:p/>
+        </p:txBody>
       </p:sp>
       <p:sp>
         <p:nvSpPr>
@@ -15005,6 +15028,10 @@
             </a:outerShdw>
           </a:effectLst>
         </p:spPr>
+        <p:txBody>
+          <a:bodyPr/>
+          <a:p/>
+        </p:txBody>
       </p:sp>
       <p:pic>
         <p:nvPicPr>
@@ -15185,6 +15212,10 @@
             </a:outerShdw>
           </a:effectLst>
         </p:spPr>
+        <p:txBody>
+          <a:bodyPr/>
+          <a:p/>
+        </p:txBody>
       </p:sp>
       <p:sp>
         <p:nvSpPr>
@@ -15211,6 +15242,10 @@
             </a:outerShdw>
           </a:effectLst>
         </p:spPr>
+        <p:txBody>
+          <a:bodyPr/>
+          <a:p/>
+        </p:txBody>
       </p:sp>
       <p:pic>
         <p:nvPicPr>
@@ -15391,6 +15426,10 @@
             </a:outerShdw>
           </a:effectLst>
         </p:spPr>
+        <p:txBody>
+          <a:bodyPr/>
+          <a:p/>
+        </p:txBody>
       </p:sp>
       <p:sp>
         <p:nvSpPr>
@@ -15417,6 +15456,10 @@
             </a:outerShdw>
           </a:effectLst>
         </p:spPr>
+        <p:txBody>
+          <a:bodyPr/>
+          <a:p/>
+        </p:txBody>
       </p:sp>
       <p:pic>
         <p:nvPicPr>
@@ -15597,6 +15640,10 @@
             </a:outerShdw>
           </a:effectLst>
         </p:spPr>
+        <p:txBody>
+          <a:bodyPr/>
+          <a:p/>
+        </p:txBody>
       </p:sp>
       <p:sp>
         <p:nvSpPr>
@@ -15623,6 +15670,10 @@
             </a:outerShdw>
           </a:effectLst>
         </p:spPr>
+        <p:txBody>
+          <a:bodyPr/>
+          <a:p/>
+        </p:txBody>
       </p:sp>
       <p:pic>
         <p:nvPicPr>
@@ -15803,6 +15854,10 @@
             </a:outerShdw>
           </a:effectLst>
         </p:spPr>
+        <p:txBody>
+          <a:bodyPr/>
+          <a:p/>
+        </p:txBody>
       </p:sp>
       <p:sp>
         <p:nvSpPr>
@@ -15829,6 +15884,10 @@
             </a:outerShdw>
           </a:effectLst>
         </p:spPr>
+        <p:txBody>
+          <a:bodyPr/>
+          <a:p/>
+        </p:txBody>
       </p:sp>
       <p:pic>
         <p:nvPicPr>
@@ -16009,6 +16068,10 @@
             </a:outerShdw>
           </a:effectLst>
         </p:spPr>
+        <p:txBody>
+          <a:bodyPr/>
+          <a:p/>
+        </p:txBody>
       </p:sp>
       <p:sp>
         <p:nvSpPr>
@@ -16035,6 +16098,10 @@
             </a:outerShdw>
           </a:effectLst>
         </p:spPr>
+        <p:txBody>
+          <a:bodyPr/>
+          <a:p/>
+        </p:txBody>
       </p:sp>
       <p:pic>
         <p:nvPicPr>
@@ -16215,6 +16282,10 @@
             </a:outerShdw>
           </a:effectLst>
         </p:spPr>
+        <p:txBody>
+          <a:bodyPr/>
+          <a:p/>
+        </p:txBody>
       </p:sp>
       <p:sp>
         <p:nvSpPr>
@@ -16241,6 +16312,10 @@
             </a:outerShdw>
           </a:effectLst>
         </p:spPr>
+        <p:txBody>
+          <a:bodyPr/>
+          <a:p/>
+        </p:txBody>
       </p:sp>
       <p:pic>
         <p:nvPicPr>
@@ -16421,6 +16496,10 @@
             </a:outerShdw>
           </a:effectLst>
         </p:spPr>
+        <p:txBody>
+          <a:bodyPr/>
+          <a:p/>
+        </p:txBody>
       </p:sp>
       <p:sp>
         <p:nvSpPr>
@@ -16447,6 +16526,10 @@
             </a:outerShdw>
           </a:effectLst>
         </p:spPr>
+        <p:txBody>
+          <a:bodyPr/>
+          <a:p/>
+        </p:txBody>
       </p:sp>
       <p:pic>
         <p:nvPicPr>
@@ -16627,6 +16710,10 @@
             </a:outerShdw>
           </a:effectLst>
         </p:spPr>
+        <p:txBody>
+          <a:bodyPr/>
+          <a:p/>
+        </p:txBody>
       </p:sp>
       <p:sp>
         <p:nvSpPr>
@@ -16653,6 +16740,10 @@
             </a:outerShdw>
           </a:effectLst>
         </p:spPr>
+        <p:txBody>
+          <a:bodyPr/>
+          <a:p/>
+        </p:txBody>
       </p:sp>
       <p:pic>
         <p:nvPicPr>
@@ -16975,6 +17066,10 @@
             </a:outerShdw>
           </a:effectLst>
         </p:spPr>
+        <p:txBody>
+          <a:bodyPr/>
+          <a:p/>
+        </p:txBody>
       </p:sp>
       <p:sp>
         <p:nvSpPr>
@@ -17082,6 +17177,10 @@
             </a:outerShdw>
           </a:effectLst>
         </p:spPr>
+        <p:txBody>
+          <a:bodyPr/>
+          <a:p/>
+        </p:txBody>
       </p:sp>
       <p:sp>
         <p:nvSpPr>
@@ -17255,6 +17354,10 @@
             </a:outerShdw>
           </a:effectLst>
         </p:spPr>
+        <p:txBody>
+          <a:bodyPr/>
+          <a:p/>
+        </p:txBody>
       </p:sp>
       <p:sp>
         <p:nvSpPr>
@@ -17391,6 +17494,10 @@
             <a:srgbClr val="156D4F"/>
           </a:solidFill>
         </p:spPr>
+        <p:txBody>
+          <a:bodyPr/>
+          <a:p/>
+        </p:txBody>
       </p:sp>
       <p:pic>
         <p:nvPicPr>
@@ -17440,6 +17547,10 @@
             </a:srgbClr>
           </a:solidFill>
         </p:spPr>
+        <p:txBody>
+          <a:bodyPr/>
+          <a:p/>
+        </p:txBody>
       </p:sp>
       <p:sp>
         <p:nvSpPr>
@@ -19857,6 +19968,10 @@
             <a:srgbClr val="156D4F"/>
           </a:solidFill>
         </p:spPr>
+        <p:txBody>
+          <a:bodyPr/>
+          <a:p/>
+        </p:txBody>
       </p:sp>
       <p:pic>
         <p:nvPicPr>
@@ -19906,6 +20021,10 @@
             </a:srgbClr>
           </a:solidFill>
         </p:spPr>
+        <p:txBody>
+          <a:bodyPr/>
+          <a:p/>
+        </p:txBody>
       </p:sp>
       <p:sp>
         <p:nvSpPr>
@@ -20122,6 +20241,10 @@
             </a:outerShdw>
           </a:effectLst>
         </p:spPr>
+        <p:txBody>
+          <a:bodyPr/>
+          <a:p/>
+        </p:txBody>
       </p:sp>
       <p:sp>
         <p:nvSpPr>
@@ -20148,6 +20271,10 @@
             </a:outerShdw>
           </a:effectLst>
         </p:spPr>
+        <p:txBody>
+          <a:bodyPr/>
+          <a:p/>
+        </p:txBody>
       </p:sp>
       <p:pic>
         <p:nvPicPr>
@@ -20628,6 +20755,10 @@
             </a:outerShdw>
           </a:effectLst>
         </p:spPr>
+        <p:txBody>
+          <a:bodyPr/>
+          <a:p/>
+        </p:txBody>
       </p:sp>
       <p:sp>
         <p:nvSpPr>
@@ -20654,6 +20785,10 @@
             </a:outerShdw>
           </a:effectLst>
         </p:spPr>
+        <p:txBody>
+          <a:bodyPr/>
+          <a:p/>
+        </p:txBody>
       </p:sp>
       <p:pic>
         <p:nvPicPr>
@@ -21066,15 +21201,7 @@
               <a:buNone/>
             </a:pPr>
             <a:r>
-              <a:rPr lang="en-US" sz="1200" dirty="0">
-                <a:solidFill>
-                  <a:srgbClr val="364327"/>
-                </a:solidFill>
-                <a:latin typeface="Segoe UI" panose="020B0502040204020203" pitchFamily="34" charset="0"/>
-                <a:ea typeface="Segoe UI" panose="020B0502040204020203" pitchFamily="34" charset="-122"/>
-                <a:cs typeface="Segoe UI" panose="020B0502040204020203" pitchFamily="34" charset="-120"/>
-              </a:rPr>
-              <a:t>Layer 5: Cognitive Reasoning — Manages Gemini/OpenAI prompts for natural-language advice.</a:t>
+              <a:t>Layer 5: Cognitive Reasoning — Manages Groq API (Llama-3.3-70b) prompts &amp; local grounded fallback for advice.</a:t>
             </a:r>
             <a:endParaRPr lang="en-US" sz="1200" dirty="0"/>
           </a:p>
@@ -21196,15 +21323,7 @@
               <a:buNone/>
             </a:pPr>
             <a:r>
-              <a:rPr lang="en-US" sz="1200" dirty="0">
-                <a:solidFill>
-                  <a:srgbClr val="364327"/>
-                </a:solidFill>
-                <a:latin typeface="Segoe UI" panose="020B0502040204020203" pitchFamily="34" charset="0"/>
-                <a:ea typeface="Segoe UI" panose="020B0502040204020203" pitchFamily="34" charset="-122"/>
-                <a:cs typeface="Segoe UI" panose="020B0502040204020203" pitchFamily="34" charset="-120"/>
-              </a:rPr>
-              <a:t>Layer 7: Verification &amp; Audit — Runs geolocation, QR, and hash chains for eco-action proofs.</a:t>
+              <a:t>Layer 7: Verification &amp; Audit — Runs MongoDB 2dsphere geofencing, MinIO S3 proof storage, and Tesseract OCR.</a:t>
             </a:r>
             <a:endParaRPr lang="en-US" sz="1200" dirty="0"/>
           </a:p>
@@ -21228,6 +21347,10 @@
             <a:srgbClr val="156D4F"/>
           </a:solidFill>
         </p:spPr>
+        <p:txBody>
+          <a:bodyPr/>
+          <a:p/>
+        </p:txBody>
       </p:sp>
       <p:pic>
         <p:nvPicPr>
@@ -21277,6 +21400,10 @@
             </a:srgbClr>
           </a:solidFill>
         </p:spPr>
+        <p:txBody>
+          <a:bodyPr/>
+          <a:p/>
+        </p:txBody>
       </p:sp>
       <p:sp>
         <p:nvSpPr>
@@ -21630,25 +21757,9 @@
                     <a:bodyPr/>
                     <a:lstStyle/>
                     <a:p>
-                      <a:pPr marL="0" indent="0">
-                        <a:buNone/>
-                      </a:pPr>
                       <a:r>
-                        <a:rPr lang="en-US" sz="1200" dirty="0">
-                          <a:solidFill>
-                            <a:srgbClr val="156D4F"/>
-                          </a:solidFill>
-                          <a:latin typeface="Segoe UI" panose="020B0502040204020203" pitchFamily="34" charset="0"/>
-                          <a:ea typeface="Segoe UI" panose="020B0502040204020203" pitchFamily="34" charset="-122"/>
-                          <a:cs typeface="Segoe UI" panose="020B0502040204020203" pitchFamily="34" charset="-120"/>
-                        </a:rPr>
                         <a:t>Frontend Framework</a:t>
                       </a:r>
-                      <a:endParaRPr lang="en-US" sz="1200" dirty="0">
-                        <a:latin typeface="Segoe UI" panose="020B0502040204020203" pitchFamily="34" charset="0"/>
-                        <a:ea typeface="Segoe UI" panose="020B0502040204020203" pitchFamily="34" charset="0"/>
-                        <a:cs typeface="Segoe UI" panose="020B0502040204020203" pitchFamily="34" charset="0"/>
-                      </a:endParaRPr>
                     </a:p>
                   </a:txBody>
                   <a:tcPr anchor="ctr">
@@ -21695,25 +21806,9 @@
                     <a:bodyPr/>
                     <a:lstStyle/>
                     <a:p>
-                      <a:pPr marL="0" indent="0">
-                        <a:buNone/>
-                      </a:pPr>
                       <a:r>
-                        <a:rPr lang="en-US" sz="1200" dirty="0">
-                          <a:solidFill>
-                            <a:srgbClr val="156D4F"/>
-                          </a:solidFill>
-                          <a:latin typeface="Segoe UI" panose="020B0502040204020203" pitchFamily="34" charset="0"/>
-                          <a:ea typeface="Segoe UI" panose="020B0502040204020203" pitchFamily="34" charset="-122"/>
-                          <a:cs typeface="Segoe UI" panose="020B0502040204020203" pitchFamily="34" charset="-120"/>
-                        </a:rPr>
-                        <a:t>React.js + TypeScript, styling with Tailwind CSS and Material UI dashboards.</a:t>
+                        <a:t>React 18 Spatial Canvas + Emerald Oasis theme, Groq AI Omnibar, 3-Mode View Switcher.</a:t>
                       </a:r>
-                      <a:endParaRPr lang="en-US" sz="1200" dirty="0">
-                        <a:latin typeface="Segoe UI" panose="020B0502040204020203" pitchFamily="34" charset="0"/>
-                        <a:ea typeface="Segoe UI" panose="020B0502040204020203" pitchFamily="34" charset="0"/>
-                        <a:cs typeface="Segoe UI" panose="020B0502040204020203" pitchFamily="34" charset="0"/>
-                      </a:endParaRPr>
                     </a:p>
                   </a:txBody>
                   <a:tcPr anchor="ctr">
@@ -21762,25 +21857,9 @@
                     <a:bodyPr/>
                     <a:lstStyle/>
                     <a:p>
-                      <a:pPr marL="0" indent="0">
-                        <a:buNone/>
-                      </a:pPr>
                       <a:r>
-                        <a:rPr lang="en-US" sz="1200" dirty="0">
-                          <a:solidFill>
-                            <a:srgbClr val="156D4F"/>
-                          </a:solidFill>
-                          <a:latin typeface="Segoe UI" panose="020B0502040204020203" pitchFamily="34" charset="0"/>
-                          <a:ea typeface="Segoe UI" panose="020B0502040204020203" pitchFamily="34" charset="-122"/>
-                          <a:cs typeface="Segoe UI" panose="020B0502040204020203" pitchFamily="34" charset="-120"/>
-                        </a:rPr>
                         <a:t>Backend Gateway</a:t>
                       </a:r>
-                      <a:endParaRPr lang="en-US" sz="1200" dirty="0">
-                        <a:latin typeface="Segoe UI" panose="020B0502040204020203" pitchFamily="34" charset="0"/>
-                        <a:ea typeface="Segoe UI" panose="020B0502040204020203" pitchFamily="34" charset="0"/>
-                        <a:cs typeface="Segoe UI" panose="020B0502040204020203" pitchFamily="34" charset="0"/>
-                      </a:endParaRPr>
                     </a:p>
                   </a:txBody>
                   <a:tcPr anchor="ctr">
@@ -21827,25 +21906,9 @@
                     <a:bodyPr/>
                     <a:lstStyle/>
                     <a:p>
-                      <a:pPr marL="0" indent="0">
-                        <a:buNone/>
-                      </a:pPr>
                       <a:r>
-                        <a:rPr lang="en-US" sz="1200" dirty="0">
-                          <a:solidFill>
-                            <a:srgbClr val="156D4F"/>
-                          </a:solidFill>
-                          <a:latin typeface="Segoe UI" panose="020B0502040204020203" pitchFamily="34" charset="0"/>
-                          <a:ea typeface="Segoe UI" panose="020B0502040204020203" pitchFamily="34" charset="-122"/>
-                          <a:cs typeface="Segoe UI" panose="020B0502040204020203" pitchFamily="34" charset="-120"/>
-                        </a:rPr>
-                        <a:t>Spring Boot 3, Spring Security with JWT tokens, and Hibernate for database ORM.</a:t>
+                        <a:t>Spring Boot 3.2, Spring Security with JWT tokens, and Spring Data MongoDB.</a:t>
                       </a:r>
-                      <a:endParaRPr lang="en-US" sz="1200" dirty="0">
-                        <a:latin typeface="Segoe UI" panose="020B0502040204020203" pitchFamily="34" charset="0"/>
-                        <a:ea typeface="Segoe UI" panose="020B0502040204020203" pitchFamily="34" charset="0"/>
-                        <a:cs typeface="Segoe UI" panose="020B0502040204020203" pitchFamily="34" charset="0"/>
-                      </a:endParaRPr>
                     </a:p>
                   </a:txBody>
                   <a:tcPr anchor="ctr">
@@ -21894,25 +21957,9 @@
                     <a:bodyPr/>
                     <a:lstStyle/>
                     <a:p>
-                      <a:pPr marL="0" indent="0">
-                        <a:buNone/>
-                      </a:pPr>
                       <a:r>
-                        <a:rPr lang="en-US" sz="1200" dirty="0">
-                          <a:solidFill>
-                            <a:srgbClr val="156D4F"/>
-                          </a:solidFill>
-                          <a:latin typeface="Segoe UI" panose="020B0502040204020203" pitchFamily="34" charset="0"/>
-                          <a:ea typeface="Segoe UI" panose="020B0502040204020203" pitchFamily="34" charset="-122"/>
-                          <a:cs typeface="Segoe UI" panose="020B0502040204020203" pitchFamily="34" charset="-120"/>
-                        </a:rPr>
-                        <a:t>Data &amp; Caching</a:t>
+                        <a:t>Data &amp; Storage</a:t>
                       </a:r>
-                      <a:endParaRPr lang="en-US" sz="1200" dirty="0">
-                        <a:latin typeface="Segoe UI" panose="020B0502040204020203" pitchFamily="34" charset="0"/>
-                        <a:ea typeface="Segoe UI" panose="020B0502040204020203" pitchFamily="34" charset="0"/>
-                        <a:cs typeface="Segoe UI" panose="020B0502040204020203" pitchFamily="34" charset="0"/>
-                      </a:endParaRPr>
                     </a:p>
                   </a:txBody>
                   <a:tcPr anchor="ctr">
@@ -21959,25 +22006,9 @@
                     <a:bodyPr/>
                     <a:lstStyle/>
                     <a:p>
-                      <a:pPr marL="0" indent="0">
-                        <a:buNone/>
-                      </a:pPr>
                       <a:r>
-                        <a:rPr lang="en-US" sz="1200" dirty="0">
-                          <a:solidFill>
-                            <a:srgbClr val="156D4F"/>
-                          </a:solidFill>
-                          <a:latin typeface="Segoe UI" panose="020B0502040204020203" pitchFamily="34" charset="0"/>
-                          <a:ea typeface="Segoe UI" panose="020B0502040204020203" pitchFamily="34" charset="-122"/>
-                          <a:cs typeface="Segoe UI" panose="020B0502040204020203" pitchFamily="34" charset="-120"/>
-                        </a:rPr>
-                        <a:t>PostgreSQL (with PostGIS for geo-queries), Redis cache, and MinIO/S3 for evidence images.</a:t>
+                        <a:t>MongoDB 7.0 (2dsphere spatial index), MinIO / AWS S3 object storage for bill proof photos and OCR.</a:t>
                       </a:r>
-                      <a:endParaRPr lang="en-US" sz="1200" dirty="0">
-                        <a:latin typeface="Segoe UI" panose="020B0502040204020203" pitchFamily="34" charset="0"/>
-                        <a:ea typeface="Segoe UI" panose="020B0502040204020203" pitchFamily="34" charset="0"/>
-                        <a:cs typeface="Segoe UI" panose="020B0502040204020203" pitchFamily="34" charset="0"/>
-                      </a:endParaRPr>
                     </a:p>
                   </a:txBody>
                   <a:tcPr anchor="ctr">
@@ -22026,25 +22057,9 @@
                     <a:bodyPr/>
                     <a:lstStyle/>
                     <a:p>
-                      <a:pPr marL="0" indent="0">
-                        <a:buNone/>
-                      </a:pPr>
                       <a:r>
-                        <a:rPr lang="en-US" sz="1200" dirty="0">
-                          <a:solidFill>
-                            <a:srgbClr val="156D4F"/>
-                          </a:solidFill>
-                          <a:latin typeface="Segoe UI" panose="020B0502040204020203" pitchFamily="34" charset="0"/>
-                          <a:ea typeface="Segoe UI" panose="020B0502040204020203" pitchFamily="34" charset="-122"/>
-                          <a:cs typeface="Segoe UI" panose="020B0502040204020203" pitchFamily="34" charset="-120"/>
-                        </a:rPr>
                         <a:t>Machine Learning</a:t>
                       </a:r>
-                      <a:endParaRPr lang="en-US" sz="1200" dirty="0">
-                        <a:latin typeface="Segoe UI" panose="020B0502040204020203" pitchFamily="34" charset="0"/>
-                        <a:ea typeface="Segoe UI" panose="020B0502040204020203" pitchFamily="34" charset="0"/>
-                        <a:cs typeface="Segoe UI" panose="020B0502040204020203" pitchFamily="34" charset="0"/>
-                      </a:endParaRPr>
                     </a:p>
                   </a:txBody>
                   <a:tcPr anchor="ctr">
@@ -22091,25 +22106,9 @@
                     <a:bodyPr/>
                     <a:lstStyle/>
                     <a:p>
-                      <a:pPr marL="0" indent="0">
-                        <a:buNone/>
-                      </a:pPr>
                       <a:r>
-                        <a:rPr lang="en-US" sz="1200" dirty="0">
-                          <a:solidFill>
-                            <a:srgbClr val="156D4F"/>
-                          </a:solidFill>
-                          <a:latin typeface="Segoe UI" panose="020B0502040204020203" pitchFamily="34" charset="0"/>
-                          <a:ea typeface="Segoe UI" panose="020B0502040204020203" pitchFamily="34" charset="-122"/>
-                          <a:cs typeface="Segoe UI" panose="020B0502040204020203" pitchFamily="34" charset="-120"/>
-                        </a:rPr>
-                        <a:t>FastAPI (Python 3.11), scikit-learn, XGBoost, pandas, NumPy forecasting.</a:t>
+                        <a:t>FastAPI (Python 3.11), scikit-learn IsolationForest anomaly engine, XGBoost regression (30-day forecast).</a:t>
                       </a:r>
-                      <a:endParaRPr lang="en-US" sz="1200" dirty="0">
-                        <a:latin typeface="Segoe UI" panose="020B0502040204020203" pitchFamily="34" charset="0"/>
-                        <a:ea typeface="Segoe UI" panose="020B0502040204020203" pitchFamily="34" charset="0"/>
-                        <a:cs typeface="Segoe UI" panose="020B0502040204020203" pitchFamily="34" charset="0"/>
-                      </a:endParaRPr>
                     </a:p>
                   </a:txBody>
                   <a:tcPr anchor="ctr">
@@ -22158,25 +22157,9 @@
                     <a:bodyPr/>
                     <a:lstStyle/>
                     <a:p>
-                      <a:pPr marL="0" indent="0">
-                        <a:buNone/>
-                      </a:pPr>
                       <a:r>
-                        <a:rPr lang="en-US" sz="1200" dirty="0">
-                          <a:solidFill>
-                            <a:srgbClr val="156D4F"/>
-                          </a:solidFill>
-                          <a:latin typeface="Segoe UI" panose="020B0502040204020203" pitchFamily="34" charset="0"/>
-                          <a:ea typeface="Segoe UI" panose="020B0502040204020203" pitchFamily="34" charset="-122"/>
-                          <a:cs typeface="Segoe UI" panose="020B0502040204020203" pitchFamily="34" charset="-120"/>
-                        </a:rPr>
                         <a:t>Optimization Solver</a:t>
                       </a:r>
-                      <a:endParaRPr lang="en-US" sz="1200" dirty="0">
-                        <a:latin typeface="Segoe UI" panose="020B0502040204020203" pitchFamily="34" charset="0"/>
-                        <a:ea typeface="Segoe UI" panose="020B0502040204020203" pitchFamily="34" charset="0"/>
-                        <a:cs typeface="Segoe UI" panose="020B0502040204020203" pitchFamily="34" charset="0"/>
-                      </a:endParaRPr>
                     </a:p>
                   </a:txBody>
                   <a:tcPr anchor="ctr">
@@ -22223,25 +22206,9 @@
                     <a:bodyPr/>
                     <a:lstStyle/>
                     <a:p>
-                      <a:pPr marL="0" indent="0">
-                        <a:buNone/>
-                      </a:pPr>
                       <a:r>
-                        <a:rPr lang="en-US" sz="1200" dirty="0">
-                          <a:solidFill>
-                            <a:srgbClr val="156D4F"/>
-                          </a:solidFill>
-                          <a:latin typeface="Segoe UI" panose="020B0502040204020203" pitchFamily="34" charset="0"/>
-                          <a:ea typeface="Segoe UI" panose="020B0502040204020203" pitchFamily="34" charset="-122"/>
-                          <a:cs typeface="Segoe UI" panose="020B0502040204020203" pitchFamily="34" charset="-120"/>
-                        </a:rPr>
-                        <a:t>Google OR-Tools for multi-objective resource (carbon/cost) constraint solving.</a:t>
+                        <a:t>Google OR-Tools Mixed-Integer Linear Programming (MILP solver with pywraplp).</a:t>
                       </a:r>
-                      <a:endParaRPr lang="en-US" sz="1200" dirty="0">
-                        <a:latin typeface="Segoe UI" panose="020B0502040204020203" pitchFamily="34" charset="0"/>
-                        <a:ea typeface="Segoe UI" panose="020B0502040204020203" pitchFamily="34" charset="0"/>
-                        <a:cs typeface="Segoe UI" panose="020B0502040204020203" pitchFamily="34" charset="0"/>
-                      </a:endParaRPr>
                     </a:p>
                   </a:txBody>
                   <a:tcPr anchor="ctr">
@@ -22290,25 +22257,9 @@
                     <a:bodyPr/>
                     <a:lstStyle/>
                     <a:p>
-                      <a:pPr marL="0" indent="0">
-                        <a:buNone/>
-                      </a:pPr>
                       <a:r>
-                        <a:rPr lang="en-US" sz="1200" dirty="0">
-                          <a:solidFill>
-                            <a:srgbClr val="156D4F"/>
-                          </a:solidFill>
-                          <a:latin typeface="Segoe UI" panose="020B0502040204020203" pitchFamily="34" charset="0"/>
-                          <a:ea typeface="Segoe UI" panose="020B0502040204020203" pitchFamily="34" charset="-122"/>
-                          <a:cs typeface="Segoe UI" panose="020B0502040204020203" pitchFamily="34" charset="-120"/>
-                        </a:rPr>
-                        <a:t>External integrations</a:t>
+                        <a:t>AI &amp; External APIs</a:t>
                       </a:r>
-                      <a:endParaRPr lang="en-US" sz="1200" dirty="0">
-                        <a:latin typeface="Segoe UI" panose="020B0502040204020203" pitchFamily="34" charset="0"/>
-                        <a:ea typeface="Segoe UI" panose="020B0502040204020203" pitchFamily="34" charset="0"/>
-                        <a:cs typeface="Segoe UI" panose="020B0502040204020203" pitchFamily="34" charset="0"/>
-                      </a:endParaRPr>
                     </a:p>
                   </a:txBody>
                   <a:tcPr anchor="ctr">
@@ -22355,25 +22306,9 @@
                     <a:bodyPr/>
                     <a:lstStyle/>
                     <a:p>
-                      <a:pPr marL="0" indent="0">
-                        <a:buNone/>
-                      </a:pPr>
                       <a:r>
-                        <a:rPr lang="en-US" sz="1200" dirty="0">
-                          <a:solidFill>
-                            <a:srgbClr val="156D4F"/>
-                          </a:solidFill>
-                          <a:latin typeface="Segoe UI" panose="020B0502040204020203" pitchFamily="34" charset="0"/>
-                          <a:ea typeface="Segoe UI" panose="020B0502040204020203" pitchFamily="34" charset="-122"/>
-                          <a:cs typeface="Segoe UI" panose="020B0502040204020203" pitchFamily="34" charset="-120"/>
-                        </a:rPr>
-                        <a:t>Leaflet.js + OpenStreetMap, OpenWeather API, AQICN Air Quality, Nominatim geocoder.</a:t>
+                        <a:t>Groq API Gateway (Llama-3.3-70b-versatile) + Local Grounded Fallback Engine, OpenWeather &amp; AQICN APIs.</a:t>
                       </a:r>
-                      <a:endParaRPr lang="en-US" sz="1200" dirty="0">
-                        <a:latin typeface="Segoe UI" panose="020B0502040204020203" pitchFamily="34" charset="0"/>
-                        <a:ea typeface="Segoe UI" panose="020B0502040204020203" pitchFamily="34" charset="0"/>
-                        <a:cs typeface="Segoe UI" panose="020B0502040204020203" pitchFamily="34" charset="0"/>
-                      </a:endParaRPr>
                     </a:p>
                   </a:txBody>
                   <a:tcPr anchor="ctr">
@@ -22447,6 +22382,10 @@
             </a:outerShdw>
           </a:effectLst>
         </p:spPr>
+        <p:txBody>
+          <a:bodyPr/>
+          <a:p/>
+        </p:txBody>
       </p:sp>
       <p:sp>
         <p:nvSpPr>
@@ -22512,6 +22451,10 @@
             <a:prstDash val="solid"/>
           </a:ln>
         </p:spPr>
+        <p:txBody>
+          <a:bodyPr/>
+          <a:p/>
+        </p:txBody>
       </p:sp>
       <p:sp>
         <p:nvSpPr>
@@ -22577,6 +22520,10 @@
             <a:prstDash val="solid"/>
           </a:ln>
         </p:spPr>
+        <p:txBody>
+          <a:bodyPr/>
+          <a:p/>
+        </p:txBody>
       </p:sp>
       <p:sp>
         <p:nvSpPr>
@@ -22642,6 +22589,10 @@
             <a:prstDash val="solid"/>
           </a:ln>
         </p:spPr>
+        <p:txBody>
+          <a:bodyPr/>
+          <a:p/>
+        </p:txBody>
       </p:sp>
       <p:sp>
         <p:nvSpPr>
@@ -22707,6 +22658,10 @@
             <a:prstDash val="solid"/>
           </a:ln>
         </p:spPr>
+        <p:txBody>
+          <a:bodyPr/>
+          <a:p/>
+        </p:txBody>
       </p:sp>
       <p:sp>
         <p:nvSpPr>
@@ -22772,6 +22727,10 @@
             <a:prstDash val="solid"/>
           </a:ln>
         </p:spPr>
+        <p:txBody>
+          <a:bodyPr/>
+          <a:p/>
+        </p:txBody>
       </p:sp>
       <p:sp>
         <p:nvSpPr>
@@ -22837,6 +22796,10 @@
             <a:prstDash val="solid"/>
           </a:ln>
         </p:spPr>
+        <p:txBody>
+          <a:bodyPr/>
+          <a:p/>
+        </p:txBody>
       </p:sp>
       <p:sp>
         <p:nvSpPr>
@@ -22924,15 +22887,7 @@
               <a:buNone/>
             </a:pPr>
             <a:r>
-              <a:rPr lang="en-US" sz="1200" dirty="0">
-                <a:solidFill>
-                  <a:srgbClr val="364327"/>
-                </a:solidFill>
-                <a:latin typeface="Segoe UI" panose="020B0502040204020203" pitchFamily="34" charset="0"/>
-                <a:ea typeface="Segoe UI" panose="020B0502040204020203" pitchFamily="34" charset="-122"/>
-                <a:cs typeface="Segoe UI" panose="020B0502040204020203" pitchFamily="34" charset="-120"/>
-              </a:rPr>
-              <a:t>PostGIS Coordinates Tree Planting Spots</a:t>
+              <a:t>MongoDB 2dsphere Geofences Campus Radius</a:t>
             </a:r>
             <a:endParaRPr lang="en-US" sz="1200" dirty="0"/>
           </a:p>
@@ -23110,15 +23065,7 @@
               <a:buNone/>
             </a:pPr>
             <a:r>
-              <a:rPr lang="en-US" sz="1200" dirty="0">
-                <a:solidFill>
-                  <a:srgbClr val="364327"/>
-                </a:solidFill>
-                <a:latin typeface="Segoe UI" panose="020B0502040204020203" pitchFamily="34" charset="0"/>
-                <a:ea typeface="Segoe UI" panose="020B0502040204020203" pitchFamily="34" charset="-122"/>
-                <a:cs typeface="Segoe UI" panose="020B0502040204020203" pitchFamily="34" charset="-120"/>
-              </a:rPr>
-              <a:t>Gemini API Demystifies Recommendation Logic</a:t>
+              <a:t>Groq LLM Gateway Explains Decision Logic</a:t>
             </a:r>
             <a:endParaRPr lang="en-US" sz="1200" dirty="0"/>
           </a:p>
@@ -23159,6 +23106,10 @@
             </a:outerShdw>
           </a:effectLst>
         </p:spPr>
+        <p:txBody>
+          <a:bodyPr/>
+          <a:p/>
+        </p:txBody>
       </p:sp>
       <p:pic>
         <p:nvPicPr>
@@ -23245,6 +23196,10 @@
             <a:srgbClr val="156D4F"/>
           </a:solidFill>
         </p:spPr>
+        <p:txBody>
+          <a:bodyPr/>
+          <a:p/>
+        </p:txBody>
       </p:sp>
       <p:pic>
         <p:nvPicPr>
@@ -23294,6 +23249,10 @@
             </a:srgbClr>
           </a:solidFill>
         </p:spPr>
+        <p:txBody>
+          <a:bodyPr/>
+          <a:p/>
+        </p:txBody>
       </p:sp>
       <p:sp>
         <p:nvSpPr>

</xml_diff>